<commit_message>
sd-12-014 deck: slide 5 says two matches; PPTX re-exported
Co-Authored-By: Claude Sonnet 5.5 <noreply@anthropic.com>
Claude-Session: https://claude.ai/code/session_01YWnTQqPDLSbUsxkfwNWsvG
</commit_message>
<xml_diff>
--- a/system-design-101/vi/lessons/sd-12-014/slides/sd-12-014.pptx
+++ b/system-design-101/vi/lessons/sd-12-014/slides/sd-12-014.pptx
@@ -6881,7 +6881,7 @@
               <a:t>Hai</a:t>
             </a:r>
             <a:r>
-              <a:rPr lang="en-US" sz="2400" b="1" dirty="0" spc="1" kern="0">
+              <a:rPr lang="en-US" sz="2400" b="1" dirty="0" spc="0" kern="0">
                 <a:solidFill>
                   <a:srgbClr val="FF6A4D"/>
                 </a:solidFill>
@@ -6889,10 +6889,10 @@
                 <a:ea typeface="Be Vietnam Pro" pitchFamily="34" charset="-122"/>
                 <a:cs typeface="Be Vietnam Pro" pitchFamily="34" charset="-120"/>
               </a:rPr>
-              <a:t> bản</a:t>
-            </a:r>
-            <a:r>
-              <a:rPr lang="en-US" sz="2400" b="1" dirty="0" spc="10" kern="0">
+              <a:t> lần</a:t>
+            </a:r>
+            <a:r>
+              <a:rPr lang="en-US" sz="2400" b="1" dirty="0" spc="-1" kern="0">
                 <a:solidFill>
                   <a:srgbClr val="FF6A4D"/>
                 </a:solidFill>
@@ -6900,18 +6900,7 @@
                 <a:ea typeface="Be Vietnam Pro" pitchFamily="34" charset="-122"/>
                 <a:cs typeface="Be Vietnam Pro" pitchFamily="34" charset="-120"/>
               </a:rPr>
-              <a:t> thực</a:t>
-            </a:r>
-            <a:r>
-              <a:rPr lang="en-US" sz="2400" b="1" dirty="0" spc="-5" kern="0">
-                <a:solidFill>
-                  <a:srgbClr val="FF6A4D"/>
-                </a:solidFill>
-                <a:latin typeface="Be Vietnam Pro" pitchFamily="34" charset="0"/>
-                <a:ea typeface="Be Vietnam Pro" pitchFamily="34" charset="-122"/>
-                <a:cs typeface="Be Vietnam Pro" pitchFamily="34" charset="-120"/>
-              </a:rPr>
-              <a:t> hiện</a:t>
+              <a:t> khớp</a:t>
             </a:r>
             <a:endParaRPr lang="en-US" sz="2400" dirty="0"/>
           </a:p>

</xml_diff>